<commit_message>
docs: gap rerun, late weak-author rerun stopped at the deadline
- gap check now 6 of 10 jobs (cap bug fixed); report and deck updated
- changelog: decision to keep the 06:00 deadline
</commit_message>
<xml_diff>
--- a/docs/study-deck.pptx
+++ b/docs/study-deck.pptx
@@ -2292,7 +2292,7 @@
                 <a:ea typeface="Cambria" pitchFamily="34" charset="-122"/>
                 <a:cs typeface="Cambria" pitchFamily="34" charset="-120"/>
               </a:rPr>
-              <a:t>$16.38</a:t>
+              <a:t>$16.95</a:t>
             </a:r>
             <a:endParaRPr lang="en-US" sz="4000" dirty="0"/>
           </a:p>
@@ -3876,7 +3876,7 @@
                 <a:ea typeface="Cambria" pitchFamily="34" charset="-122"/>
                 <a:cs typeface="Cambria" pitchFamily="34" charset="-120"/>
               </a:rPr>
-              <a:t>Pipeline per task (all study events tagged `study`)</a:t>
+              <a:t>Pipeline per task (events tagged study)</a:t>
             </a:r>
             <a:endParaRPr lang="en-US" sz="3000" dirty="0"/>
           </a:p>
@@ -5564,7 +5564,7 @@
                             <a:srgbClr val="1B2A41"/>
                           </a:solidFill>
                         </a:rPr>
-                        <a:t>n/a</a:t>
+                        <a:t>5/5</a:t>
                       </a:r>
                       <a:endParaRPr lang="en-US" sz="1400" dirty="0"/>
                     </a:p>
@@ -6111,7 +6111,7 @@
                   <a:schemeClr val="tx2"/>
                 </a:solidFill>
               </a:rPr>
-              <a:t>Only 5 of 10 gap jobs finished before the study's budget guard stopped it (a guard bug, fixed after). Where both ran, strong beat weak: 5/5 vs 0/5 and 4/5 vs 0/5. The pair clearly differs, but the weak solver also hits the 100-turn cap often (counted invalid).</a:t>
+              <a:t>Only 6 of 10 gap jobs finished (a spend-guard bug stopped the rest). Where both ran, strong beat weak: 5/5 vs 0/5, 4/5 vs 0/5 and 5/5 vs 2/5. The pair clearly differs, but the weak solver also hits the 100-turn cap often (counted invalid).</a:t>
             </a:r>
             <a:endParaRPr lang="en-US" sz="1400" dirty="0"/>
           </a:p>

</xml_diff>